<commit_message>
Address independent ST-1 deck review and refresh export proof
</commit_message>
<xml_diff>
--- a/ST-1/decks/st1-greg-versus-fred.pptx
+++ b/ST-1/decks/st1-greg-versus-fred.pptx
@@ -516,7 +516,7 @@
           </a:p>
           <a:p>
             <a:r>
-              <a:t>Same polished grid; dry captions, understated humor, persistent 'Fictional personnel story' footer. All personnel events, dialogue and actions are invented. Source figures are analytical teaching context only.</a:t>
+              <a:t>Polished grid; dry captions and understated humor; persistent 'FICTIONAL SATIRE' footer on every internal slide. All personnel events, dialogue and actions are invented. Source figures are analytical teaching context only.</a:t>
             </a:r>
           </a:p>
           <a:p/>
@@ -619,7 +619,7 @@
           </a:p>
           <a:p>
             <a:r>
-              <a:t>Read each source with its date, recipient, measurement period and disclosure limits. All personnel actions, dialogue and incidents are invented.</a:t>
+              <a:t>Read each source with its date, recipient, measurement period and disclosure limits. All personnel actions, dialogue and incidents are invented. Preserve the visible FICTIONAL SATIRE footer.</a:t>
             </a:r>
           </a:p>
           <a:p/>
@@ -737,7 +737,7 @@
           </a:p>
           <a:p>
             <a:r>
-              <a:t>All personnel events, dialogue and actions are invented. Source figures are analytical teaching context only.</a:t>
+              <a:t>All personnel events, dialogue and actions are invented. Source figures are analytical teaching context only. Preserve the visible FICTIONAL SATIRE footer.</a:t>
             </a:r>
           </a:p>
           <a:p/>
@@ -840,7 +840,7 @@
           </a:p>
           <a:p>
             <a:r>
-              <a:t>All personnel events, dialogue and actions are invented. Source figures are analytical teaching context only.</a:t>
+              <a:t>Fred is an invented new hire, accountant/controller, with the stated fictional talents and personality. His dialogue, work and interactions are fiction. Actual contract figures retain MLB1 sourcing; no personnel allegations are factual. Preserve the visible FICTIONAL SATIRE footer.</a:t>
             </a:r>
           </a:p>
           <a:p/>
@@ -851,22 +851,22 @@
           </a:p>
           <a:p>
             <a:r>
-              <a:t>Real reported terms: $700m nominal; $2m annually in 2024–33.</a:t>
-            </a:r>
-          </a:p>
-          <a:p>
-            <a:r>
-              <a:t>Real reported deferred payments: $68m annually in 2034–43.</a:t>
-            </a:r>
-          </a:p>
-          <a:p>
-            <a:r>
-              <a:t>Approximately $46m annual CBT payroll charge is another measure.</a:t>
-            </a:r>
-          </a:p>
-          <a:p>
-            <a:r>
-              <a:t>The fictional argument is invented; the contract figures are sourced.</a:t>
+              <a:t>Fred is the agency's new accountant/controller in this fictional story.</a:t>
+            </a:r>
+          </a:p>
+          <a:p>
+            <a:r>
+              <a:t>His talents: source tracing, cash-flow reconciliation and catching a missing valuation date.</a:t>
+            </a:r>
+          </a:p>
+          <a:p>
+            <a:r>
+              <a:t>His personality: patient, precise and dryly funny. He asks each number whom it belongs to.</a:t>
+            </a:r>
+          </a:p>
+          <a:p>
+            <a:r>
+              <a:t>Real context: $700m nominal; $2m annually in 2024–33; $68m annually in 2034–43.</a:t>
             </a:r>
           </a:p>
           <a:p/>
@@ -962,7 +962,7 @@
           </a:p>
           <a:p>
             <a:r>
-              <a:t>All personnel events, dialogue and actions are invented. Source figures are analytical teaching context only.</a:t>
+              <a:t>All personnel events, dialogue and actions are invented. Source figures are analytical teaching context only. Preserve the visible FICTIONAL SATIRE footer.</a:t>
             </a:r>
           </a:p>
           <a:p/>
@@ -1065,7 +1065,7 @@
           </a:p>
           <a:p>
             <a:r>
-              <a:t>All personnel events, dialogue and actions are invented. Source figures are analytical teaching context only.</a:t>
+              <a:t>All personnel events, dialogue and actions are invented. Source figures are analytical teaching context only. Preserve the visible FICTIONAL SATIRE footer.</a:t>
             </a:r>
           </a:p>
           <a:p/>
@@ -1187,7 +1187,7 @@
           </a:p>
           <a:p>
             <a:r>
-              <a:t>All personnel events, dialogue and actions are invented. Greg is terminated from the fictional agency, causes a reception scene, returns uninvited the next day drunk, vomits in the mailroom, and leaves safely with help. No transfer, reassignment or return to employment occurs.</a:t>
+              <a:t>All personnel events, dialogue and actions are invented. Greg is terminated from the fictional agency, causes a reception scene, returns uninvited the next day drunk, vomits in the mailroom, and leaves safely with help. No transfer, reassignment or return to employment occurs. Preserve the visible FICTIONAL SATIRE footer.</a:t>
             </a:r>
           </a:p>
           <a:p/>
@@ -1290,7 +1290,7 @@
           </a:p>
           <a:p>
             <a:r>
-              <a:t>All personnel events, dialogue and actions are invented. Greg is terminated from the fictional agency, causes a reception scene, returns uninvited the next day drunk, vomits in the mailroom, and leaves safely with help. No transfer, reassignment or return to employment occurs.</a:t>
+              <a:t>All personnel events, dialogue and actions are invented. Greg is terminated from the fictional agency, causes a reception scene, returns uninvited the next day drunk, vomits in the mailroom, and leaves safely with help. No transfer, reassignment or return to employment occurs. Preserve the visible FICTIONAL SATIRE footer.</a:t>
             </a:r>
           </a:p>
           <a:p/>
@@ -1398,7 +1398,7 @@
           </a:p>
           <a:p>
             <a:r>
-              <a:t>All personnel events, dialogue and actions are invented. Greg is terminated from the fictional agency, causes a reception scene, returns uninvited the next day drunk, vomits in the mailroom, and leaves safely with help. No transfer, reassignment or return to employment occurs.</a:t>
+              <a:t>All personnel events, dialogue and actions are invented. Greg is terminated from the fictional agency, causes a reception scene, returns uninvited the next day drunk, vomits in the mailroom, and leaves safely with help. No transfer, reassignment or return to employment occurs. Preserve the visible FICTIONAL SATIRE footer.</a:t>
             </a:r>
           </a:p>
           <a:p/>
@@ -1506,7 +1506,7 @@
           </a:p>
           <a:p>
             <a:r>
-              <a:t>All personnel events, dialogue and actions are invented. Source figures are analytical teaching context only.</a:t>
+              <a:t>All personnel events, dialogue and actions are invented. Source figures are analytical teaching context only. Preserve the visible FICTIONAL SATIRE footer.</a:t>
             </a:r>
           </a:p>
           <a:p/>
@@ -4685,7 +4685,7 @@
               </a:defRPr>
             </a:pPr>
             <a:r>
-              <a:t>FICTIONAL PERSONNEL STORY | NO ACTUAL EMPLOYEE ALLEGATIONS</a:t>
+              <a:t>FICTIONAL SATIRE | NO ACTUAL EMPLOYEE ALLEGATIONS</a:t>
             </a:r>
           </a:p>
         </p:txBody>
@@ -5228,7 +5228,7 @@
               </a:defRPr>
             </a:pPr>
             <a:r>
-              <a:t>FICTIONAL PERSONNEL STORY | REAL FIGURES ARE TEACHING CONTEXT</a:t>
+              <a:t>FICTIONAL SATIRE | NO ACTUAL EMPLOYEE ALLEGATIONS</a:t>
             </a:r>
           </a:p>
         </p:txBody>
@@ -5739,7 +5739,7 @@
               </a:defRPr>
             </a:pPr>
             <a:r>
-              <a:t>FICTIONAL PERSONNEL STORY | NO ACTUAL EMPLOYEE ALLEGATIONS</a:t>
+              <a:t>FICTIONAL SATIRE | NO ACTUAL EMPLOYEE ALLEGATIONS</a:t>
             </a:r>
           </a:p>
         </p:txBody>
@@ -6367,7 +6367,7 @@
               </a:defRPr>
             </a:pPr>
             <a:r>
-              <a:t>FICTIONAL PERSONNEL STORY | NO ACTUAL EMPLOYEE ALLEGATIONS</a:t>
+              <a:t>FICTIONAL SATIRE | NO ACTUAL EMPLOYEE ALLEGATIONS</a:t>
             </a:r>
           </a:p>
         </p:txBody>
@@ -6412,7 +6412,7 @@
               </a:defRPr>
             </a:pPr>
             <a:r>
-              <a:t>Fred checks the units | real contract context</a:t>
+              <a:t>Meet Fred | the new controller checks the units</a:t>
             </a:r>
           </a:p>
         </p:txBody>
@@ -6457,7 +6457,7 @@
               </a:defRPr>
             </a:pPr>
             <a:r>
-              <a:t>Fred asked the cells to introduce themselves.</a:t>
+              <a:t>A new hire with clean arithmetic and a dry sense of humor.</a:t>
             </a:r>
           </a:p>
         </p:txBody>
@@ -6545,7 +6545,7 @@
               </a:defRPr>
             </a:pPr>
             <a:r>
-              <a:t>Real reported terms: $700m nominal; $2m annually in 2024-33.</a:t>
+              <a:t>Fred is the agency's new accountant/controller in this fictional story.</a:t>
             </a:r>
           </a:p>
         </p:txBody>
@@ -6602,6 +6602,182 @@
         <p:spPr>
           <a:xfrm>
             <a:off x="863600" y="3406775"/>
+            <a:ext cx="10541000" cy="574675"/>
+          </a:xfrm>
+          <a:prstGeom prst="rect">
+            <a:avLst/>
+          </a:prstGeom>
+          <a:noFill/>
+        </p:spPr>
+        <p:txBody>
+          <a:bodyPr wrap="none" lIns="0" rIns="0" tIns="0" bIns="0">
+            <a:spAutoFit/>
+          </a:bodyPr>
+          <a:lstStyle/>
+          <a:p>
+            <a:pPr>
+              <a:lnSpc>
+                <a:spcPts val="2521"/>
+              </a:lnSpc>
+              <a:spcBef>
+                <a:spcPts val="0"/>
+              </a:spcBef>
+              <a:spcAft>
+                <a:spcPts val="0"/>
+              </a:spcAft>
+              <a:defRPr sz="2050" b="0">
+                <a:solidFill>
+                  <a:srgbClr val="302825"/>
+                </a:solidFill>
+                <a:latin typeface="Arial"/>
+              </a:defRPr>
+            </a:pPr>
+            <a:r>
+              <a:t>His talents: source tracing, cash-flow reconciliation and catching a missing valuation date.</a:t>
+            </a:r>
+          </a:p>
+        </p:txBody>
+      </p:sp>
+      <p:sp>
+        <p:nvSpPr>
+          <p:cNvPr id="11" name="Rectangle 10"/>
+          <p:cNvSpPr/>
+          <p:nvPr/>
+        </p:nvSpPr>
+        <p:spPr>
+          <a:xfrm>
+            <a:off x="609600" y="4298950"/>
+            <a:ext cx="63500" cy="63500"/>
+          </a:xfrm>
+          <a:prstGeom prst="rect">
+            <a:avLst/>
+          </a:prstGeom>
+          <a:solidFill>
+            <a:srgbClr val="B84A32"/>
+          </a:solidFill>
+          <a:ln>
+            <a:noFill/>
+          </a:ln>
+        </p:spPr>
+        <p:style>
+          <a:lnRef idx="1">
+            <a:schemeClr val="accent1"/>
+          </a:lnRef>
+          <a:fillRef idx="3">
+            <a:schemeClr val="accent1"/>
+          </a:fillRef>
+          <a:effectRef idx="2">
+            <a:schemeClr val="accent1"/>
+          </a:effectRef>
+          <a:fontRef idx="minor">
+            <a:schemeClr val="lt1"/>
+          </a:fontRef>
+        </p:style>
+        <p:txBody>
+          <a:bodyPr rtlCol="0" anchor="ctr"/>
+          <a:lstStyle/>
+          <a:p>
+            <a:pPr algn="ctr"/>
+          </a:p>
+        </p:txBody>
+      </p:sp>
+      <p:sp>
+        <p:nvSpPr>
+          <p:cNvPr id="12" name="TextBox 11"/>
+          <p:cNvSpPr txBox="1"/>
+          <p:nvPr/>
+        </p:nvSpPr>
+        <p:spPr>
+          <a:xfrm>
+            <a:off x="863600" y="4210050"/>
+            <a:ext cx="10541000" cy="574675"/>
+          </a:xfrm>
+          <a:prstGeom prst="rect">
+            <a:avLst/>
+          </a:prstGeom>
+          <a:noFill/>
+        </p:spPr>
+        <p:txBody>
+          <a:bodyPr wrap="none" lIns="0" rIns="0" tIns="0" bIns="0">
+            <a:spAutoFit/>
+          </a:bodyPr>
+          <a:lstStyle/>
+          <a:p>
+            <a:pPr>
+              <a:lnSpc>
+                <a:spcPts val="2521"/>
+              </a:lnSpc>
+              <a:spcBef>
+                <a:spcPts val="0"/>
+              </a:spcBef>
+              <a:spcAft>
+                <a:spcPts val="0"/>
+              </a:spcAft>
+              <a:defRPr sz="2050" b="0">
+                <a:solidFill>
+                  <a:srgbClr val="302825"/>
+                </a:solidFill>
+                <a:latin typeface="Arial"/>
+              </a:defRPr>
+            </a:pPr>
+            <a:r>
+              <a:t>His personality: patient, precise and dryly funny. He asks each number whom it belongs to.</a:t>
+            </a:r>
+          </a:p>
+        </p:txBody>
+      </p:sp>
+      <p:sp>
+        <p:nvSpPr>
+          <p:cNvPr id="13" name="Rectangle 12"/>
+          <p:cNvSpPr/>
+          <p:nvPr/>
+        </p:nvSpPr>
+        <p:spPr>
+          <a:xfrm>
+            <a:off x="609600" y="5102225"/>
+            <a:ext cx="63500" cy="63500"/>
+          </a:xfrm>
+          <a:prstGeom prst="rect">
+            <a:avLst/>
+          </a:prstGeom>
+          <a:solidFill>
+            <a:srgbClr val="B84A32"/>
+          </a:solidFill>
+          <a:ln>
+            <a:noFill/>
+          </a:ln>
+        </p:spPr>
+        <p:style>
+          <a:lnRef idx="1">
+            <a:schemeClr val="accent1"/>
+          </a:lnRef>
+          <a:fillRef idx="3">
+            <a:schemeClr val="accent1"/>
+          </a:fillRef>
+          <a:effectRef idx="2">
+            <a:schemeClr val="accent1"/>
+          </a:effectRef>
+          <a:fontRef idx="minor">
+            <a:schemeClr val="lt1"/>
+          </a:fontRef>
+        </p:style>
+        <p:txBody>
+          <a:bodyPr rtlCol="0" anchor="ctr"/>
+          <a:lstStyle/>
+          <a:p>
+            <a:pPr algn="ctr"/>
+          </a:p>
+        </p:txBody>
+      </p:sp>
+      <p:sp>
+        <p:nvSpPr>
+          <p:cNvPr id="14" name="TextBox 13"/>
+          <p:cNvSpPr txBox="1"/>
+          <p:nvPr/>
+        </p:nvSpPr>
+        <p:spPr>
+          <a:xfrm>
+            <a:off x="863600" y="5013325"/>
             <a:ext cx="10541000" cy="574675"/>
           </a:xfrm>
           <a:prstGeom prst="rect">
@@ -6633,183 +6809,7 @@
               </a:defRPr>
             </a:pPr>
             <a:r>
-              <a:t>Real reported deferred payments: $68m annually in 2034-43.</a:t>
-            </a:r>
-          </a:p>
-        </p:txBody>
-      </p:sp>
-      <p:sp>
-        <p:nvSpPr>
-          <p:cNvPr id="11" name="Rectangle 10"/>
-          <p:cNvSpPr/>
-          <p:nvPr/>
-        </p:nvSpPr>
-        <p:spPr>
-          <a:xfrm>
-            <a:off x="609600" y="4298950"/>
-            <a:ext cx="63500" cy="63500"/>
-          </a:xfrm>
-          <a:prstGeom prst="rect">
-            <a:avLst/>
-          </a:prstGeom>
-          <a:solidFill>
-            <a:srgbClr val="B84A32"/>
-          </a:solidFill>
-          <a:ln>
-            <a:noFill/>
-          </a:ln>
-        </p:spPr>
-        <p:style>
-          <a:lnRef idx="1">
-            <a:schemeClr val="accent1"/>
-          </a:lnRef>
-          <a:fillRef idx="3">
-            <a:schemeClr val="accent1"/>
-          </a:fillRef>
-          <a:effectRef idx="2">
-            <a:schemeClr val="accent1"/>
-          </a:effectRef>
-          <a:fontRef idx="minor">
-            <a:schemeClr val="lt1"/>
-          </a:fontRef>
-        </p:style>
-        <p:txBody>
-          <a:bodyPr rtlCol="0" anchor="ctr"/>
-          <a:lstStyle/>
-          <a:p>
-            <a:pPr algn="ctr"/>
-          </a:p>
-        </p:txBody>
-      </p:sp>
-      <p:sp>
-        <p:nvSpPr>
-          <p:cNvPr id="12" name="TextBox 11"/>
-          <p:cNvSpPr txBox="1"/>
-          <p:nvPr/>
-        </p:nvSpPr>
-        <p:spPr>
-          <a:xfrm>
-            <a:off x="863600" y="4210050"/>
-            <a:ext cx="10541000" cy="574675"/>
-          </a:xfrm>
-          <a:prstGeom prst="rect">
-            <a:avLst/>
-          </a:prstGeom>
-          <a:noFill/>
-        </p:spPr>
-        <p:txBody>
-          <a:bodyPr wrap="none" lIns="0" rIns="0" tIns="0" bIns="0">
-            <a:spAutoFit/>
-          </a:bodyPr>
-          <a:lstStyle/>
-          <a:p>
-            <a:pPr>
-              <a:lnSpc>
-                <a:spcPts val="2583"/>
-              </a:lnSpc>
-              <a:spcBef>
-                <a:spcPts val="0"/>
-              </a:spcBef>
-              <a:spcAft>
-                <a:spcPts val="0"/>
-              </a:spcAft>
-              <a:defRPr sz="2100" b="0">
-                <a:solidFill>
-                  <a:srgbClr val="302825"/>
-                </a:solidFill>
-                <a:latin typeface="Arial"/>
-              </a:defRPr>
-            </a:pPr>
-            <a:r>
-              <a:t>Approximately $46m annual CBT payroll charge is another measure.</a:t>
-            </a:r>
-          </a:p>
-        </p:txBody>
-      </p:sp>
-      <p:sp>
-        <p:nvSpPr>
-          <p:cNvPr id="13" name="Rectangle 12"/>
-          <p:cNvSpPr/>
-          <p:nvPr/>
-        </p:nvSpPr>
-        <p:spPr>
-          <a:xfrm>
-            <a:off x="609600" y="5102225"/>
-            <a:ext cx="63500" cy="63500"/>
-          </a:xfrm>
-          <a:prstGeom prst="rect">
-            <a:avLst/>
-          </a:prstGeom>
-          <a:solidFill>
-            <a:srgbClr val="B84A32"/>
-          </a:solidFill>
-          <a:ln>
-            <a:noFill/>
-          </a:ln>
-        </p:spPr>
-        <p:style>
-          <a:lnRef idx="1">
-            <a:schemeClr val="accent1"/>
-          </a:lnRef>
-          <a:fillRef idx="3">
-            <a:schemeClr val="accent1"/>
-          </a:fillRef>
-          <a:effectRef idx="2">
-            <a:schemeClr val="accent1"/>
-          </a:effectRef>
-          <a:fontRef idx="minor">
-            <a:schemeClr val="lt1"/>
-          </a:fontRef>
-        </p:style>
-        <p:txBody>
-          <a:bodyPr rtlCol="0" anchor="ctr"/>
-          <a:lstStyle/>
-          <a:p>
-            <a:pPr algn="ctr"/>
-          </a:p>
-        </p:txBody>
-      </p:sp>
-      <p:sp>
-        <p:nvSpPr>
-          <p:cNvPr id="14" name="TextBox 13"/>
-          <p:cNvSpPr txBox="1"/>
-          <p:nvPr/>
-        </p:nvSpPr>
-        <p:spPr>
-          <a:xfrm>
-            <a:off x="863600" y="5013325"/>
-            <a:ext cx="10541000" cy="574675"/>
-          </a:xfrm>
-          <a:prstGeom prst="rect">
-            <a:avLst/>
-          </a:prstGeom>
-          <a:noFill/>
-        </p:spPr>
-        <p:txBody>
-          <a:bodyPr wrap="none" lIns="0" rIns="0" tIns="0" bIns="0">
-            <a:spAutoFit/>
-          </a:bodyPr>
-          <a:lstStyle/>
-          <a:p>
-            <a:pPr>
-              <a:lnSpc>
-                <a:spcPts val="2583"/>
-              </a:lnSpc>
-              <a:spcBef>
-                <a:spcPts val="0"/>
-              </a:spcBef>
-              <a:spcAft>
-                <a:spcPts val="0"/>
-              </a:spcAft>
-              <a:defRPr sz="2100" b="0">
-                <a:solidFill>
-                  <a:srgbClr val="302825"/>
-                </a:solidFill>
-                <a:latin typeface="Arial"/>
-              </a:defRPr>
-            </a:pPr>
-            <a:r>
-              <a:t>The fictional argument is invented; the contract figures are sourced.</a:t>
+              <a:t>Real context: $700m nominal; $2m annually in 2024-33; $68m annually in 2034-43.</a:t>
             </a:r>
           </a:p>
         </p:txBody>
@@ -7131,7 +7131,7 @@
               </a:defRPr>
             </a:pPr>
             <a:r>
-              <a:t>FICTIONAL PERSONNEL STORY | NO ACTUAL EMPLOYEE ALLEGATIONS</a:t>
+              <a:t>FICTIONAL SATIRE | NO ACTUAL EMPLOYEE ALLEGATIONS</a:t>
             </a:r>
           </a:p>
         </p:txBody>
@@ -7759,7 +7759,7 @@
               </a:defRPr>
             </a:pPr>
             <a:r>
-              <a:t>FICTIONAL PERSONNEL STORY | NO ACTUAL EMPLOYEE ALLEGATIONS</a:t>
+              <a:t>FICTIONAL SATIRE | NO ACTUAL EMPLOYEE ALLEGATIONS</a:t>
             </a:r>
           </a:p>
         </p:txBody>
@@ -8523,7 +8523,7 @@
               </a:defRPr>
             </a:pPr>
             <a:r>
-              <a:t>FICTIONAL PERSONNEL STORY | NO ACTUAL EMPLOYEE ALLEGATIONS</a:t>
+              <a:t>FICTIONAL SATIRE | NO ACTUAL EMPLOYEE ALLEGATIONS</a:t>
             </a:r>
           </a:p>
         </p:txBody>
@@ -9173,7 +9173,7 @@
               </a:defRPr>
             </a:pPr>
             <a:r>
-              <a:t>FICTIONAL PERSONNEL STORY | NO ACTUAL EMPLOYEE ALLEGATIONS</a:t>
+              <a:t>FICTIONAL SATIRE | NO ACTUAL EMPLOYEE ALLEGATIONS</a:t>
             </a:r>
           </a:p>
         </p:txBody>
@@ -9889,7 +9889,7 @@
               </a:defRPr>
             </a:pPr>
             <a:r>
-              <a:t>FICTIONAL PERSONNEL STORY | NO ACTUAL EMPLOYEE ALLEGATIONS</a:t>
+              <a:t>FICTIONAL SATIRE | NO ACTUAL EMPLOYEE ALLEGATIONS</a:t>
             </a:r>
           </a:p>
         </p:txBody>
@@ -10605,7 +10605,7 @@
               </a:defRPr>
             </a:pPr>
             <a:r>
-              <a:t>FICTIONAL PERSONNEL STORY | NO ACTUAL EMPLOYEE ALLEGATIONS</a:t>
+              <a:t>FICTIONAL SATIRE | NO ACTUAL EMPLOYEE ALLEGATIONS</a:t>
             </a:r>
           </a:p>
         </p:txBody>

</xml_diff>